<commit_message>
Update pitch deck and remove v2 duplicate
Co-Authored-By: Claude Opus 4.6 <noreply@anthropic.com>
</commit_message>
<xml_diff>
--- a/SafeCross-SF-3min.pptx
+++ b/SafeCross-SF-3min.pptx
@@ -685,7 +685,7 @@
           <a:p>
             <a:r>
               <a:rPr lang="en-US" dirty="0"/>
-              <a:t>30 seconds. 'SafeCross has three phases. Phase 1 is the MVP: a senior taps their existing Clipper card at the signal pole, and we extend the walk signal 6-13 extra seconds. Same gesture as boarding a bus — no enrollment needed. Phase 2 adds thermal sensors that detect pedestrians automatically — no card needed, works at night. Phase 3 is where AI comes in: we analyze crossing patterns across every intersection and use Gemini to generate natural-language safety recommendations for city engineers — which intersections should permanently change their timing, when, and by how much.'</a:t>
+              <a:t>30 seconds. 'SafeCross has three phases. Phase 1 is the MVP: a senior taps their existing Clipper card at the signal pole, and we extend the walk signal 6-13 extra seconds. Same gesture as boarding a bus — no enrollment needed. Phase 2 adds thermal sensors that detect pedestrians automatically — no card needed, works at night. Phase 3 is where AI comes in: Gemini Vision analyzes every crossing event — detecting vehicles in crosswalks, flagging near-misses in real time, and creating a safety dataset that doesn't exist anywhere today. It also generates natural-language timing recommendations for city engineers.'</a:t>
             </a:r>
             <a:endParaRPr lang="en-US" dirty="0"/>
           </a:p>
@@ -773,7 +773,7 @@
           <a:p>
             <a:r>
               <a:rPr lang="en-US" dirty="0"/>
-              <a:t>25 seconds. 'Here's the flow: Step 1, the senior taps their Clipper card — the NFC reader identifies it as a senior card in under 200 milliseconds. Step 2, the edge controller inside the signal cabinet calculates how much extra time based on crossing width. Step 3, it sends a standard NTCIP command to extend the walk phase — and always restores baseline timing afterward. Step 4, every tap is logged and our AI analytics engine identifies patterns and generates recommendations. Total latency under 500ms. Cost per intersection under $3,000 — cheaper than a speed bump.'</a:t>
+              <a:t>25 seconds. 'Here's the flow: Step 1, the senior taps their Clipper card — the NFC reader identifies it as a senior card in under 200 milliseconds. Step 2, the edge controller inside the signal cabinet calculates how much extra time based on crossing width. Step 3, it sends a standard NTCIP command to extend the walk phase — and always restores baseline timing afterward. Step 4, Gemini Vision analyzes the crossing scene — it identifies vehicles in the crosswalk, estimates distance, and flags near-misses. The AI also generates timing recommendations for engineers. Total latency under 500ms. Cost per intersection under $3,000 — cheaper than a speed bump.'</a:t>
             </a:r>
             <a:endParaRPr lang="en-US" dirty="0"/>
           </a:p>
@@ -861,7 +861,7 @@
           <a:p>
             <a:r>
               <a:rPr lang="en-US" dirty="0"/>
-              <a:t>25 seconds. 'The system has three compute nodes. An NFC reader on the signal pole running 900 lines of C firmware. An edge controller in the signal cabinet running 3,000 lines of Python — this handles the NTCIP protocol to the signal controller. And the cloud layer with AI analytics — Gemini-powered insights that analyze crossing patterns and generate natural-language recommendations for city engineers. Total: 9,500 lines of code. And it's fail-safe by design — if anything crashes, the traffic signal continues normally.'</a:t>
+              <a:t>25 seconds. 'The system has three compute nodes. An NFC reader on the signal pole running 900 lines of C firmware. An edge controller in the signal cabinet running 3,000 lines of Python — this handles the NTCIP protocol to the signal controller. And the cloud layer with multimodal AI — Gemini Vision analyzes every crossing event for vehicles in the crosswalk, and generates natural-language timing recommendations for city engineers. Total: 9,500 lines of code. And it's fail-safe by design — if anything crashes, the traffic signal continues normally.'</a:t>
             </a:r>
             <a:endParaRPr lang="en-US" dirty="0"/>
           </a:p>
@@ -949,7 +949,7 @@
           <a:p>
             <a:r>
               <a:rPr lang="en-US" dirty="0"/>
-              <a:t>60 seconds. This is where you switch to a live demo or screen recording. Demo sequence: 1) Run simulate_reader.py sending a senior card tap — show the terminal output with the card classification and extension grant. 2) Switch to the dashboard — show the event appearing on the Mapbox map in real time. 3) Click into the intersection detail view — show the AI insights panel where Gemini analyzes the crossing pattern data and generates a recommendation like 'Market &amp; 5th: 34 senior taps per day at 8-9am. Recommend permanent +8 second baseline extension for morning peak.' Keep it tight — 60 seconds max.</a:t>
+              <a:t>60 seconds. This is where you switch to a live demo or screen recording. Demo sequence: 1) Show the dashboard with live events flowing — point out the vision badges showing near-miss detection in real time. 2) Click into Market &amp; 5th — show the Safety Analysis section with AI-flagged vehicle detections and risk levels. 3) Click AI Recommendation — show Gemini generating a specific timing change with physics reasoning based on crossing width and walking speed. Keep it tight — 60 seconds max.</a:t>
             </a:r>
             <a:endParaRPr lang="en-US" dirty="0"/>
           </a:p>
@@ -1520,7 +1520,7 @@
       </p:sp>
       <p:pic>
         <p:nvPicPr>
-          <p:cNvPr id="3" name="Image 0" descr="preencoded.png">    </p:cNvPr>
+          <p:cNvPr id="3" name="Image 0" descr="preencoded.png"/>
           <p:cNvPicPr>
             <a:picLocks noChangeAspect="1"/>
           </p:cNvPicPr>
@@ -1875,7 +1875,7 @@
       </p:sp>
       <p:pic>
         <p:nvPicPr>
-          <p:cNvPr id="7" name="Image 0" descr="preencoded.png">    </p:cNvPr>
+          <p:cNvPr id="7" name="Image 0" descr="preencoded.png"/>
           <p:cNvPicPr>
             <a:picLocks noChangeAspect="1"/>
           </p:cNvPicPr>
@@ -2058,7 +2058,7 @@
       </p:sp>
       <p:pic>
         <p:nvPicPr>
-          <p:cNvPr id="12" name="Image 1" descr="preencoded.png">    </p:cNvPr>
+          <p:cNvPr id="12" name="Image 1" descr="preencoded.png"/>
           <p:cNvPicPr>
             <a:picLocks noChangeAspect="1"/>
           </p:cNvPicPr>
@@ -2241,7 +2241,7 @@
       </p:sp>
       <p:pic>
         <p:nvPicPr>
-          <p:cNvPr id="17" name="Image 2" descr="preencoded.png">    </p:cNvPr>
+          <p:cNvPr id="17" name="Image 2" descr="preencoded.png"/>
           <p:cNvPicPr>
             <a:picLocks noChangeAspect="1"/>
           </p:cNvPicPr>
@@ -2424,7 +2424,7 @@
       </p:sp>
       <p:pic>
         <p:nvPicPr>
-          <p:cNvPr id="22" name="Image 3" descr="preencoded.png">    </p:cNvPr>
+          <p:cNvPr id="22" name="Image 3" descr="preencoded.png"/>
           <p:cNvPicPr>
             <a:picLocks noChangeAspect="1"/>
           </p:cNvPicPr>
@@ -2657,7 +2657,7 @@
       </p:sp>
       <p:pic>
         <p:nvPicPr>
-          <p:cNvPr id="7" name="Image 0" descr="preencoded.png">    </p:cNvPr>
+          <p:cNvPr id="7" name="Image 0" descr="preencoded.png"/>
           <p:cNvPicPr>
             <a:picLocks noChangeAspect="1"/>
           </p:cNvPicPr>
@@ -2907,7 +2907,7 @@
       </p:sp>
       <p:pic>
         <p:nvPicPr>
-          <p:cNvPr id="13" name="Image 1" descr="preencoded.png">    </p:cNvPr>
+          <p:cNvPr id="13" name="Image 1" descr="preencoded.png"/>
           <p:cNvPicPr>
             <a:picLocks noChangeAspect="1"/>
           </p:cNvPicPr>
@@ -3157,7 +3157,7 @@
       </p:sp>
       <p:pic>
         <p:nvPicPr>
-          <p:cNvPr id="19" name="Image 2" descr="preencoded.png">    </p:cNvPr>
+          <p:cNvPr id="19" name="Image 2" descr="preencoded.png"/>
           <p:cNvPicPr>
             <a:picLocks noChangeAspect="1"/>
           </p:cNvPicPr>
@@ -3251,7 +3251,7 @@
                 <a:ea typeface="Calibri" pitchFamily="34" charset="-122"/>
                 <a:cs typeface="Calibri" pitchFamily="34" charset="-120"/>
               </a:rPr>
-              <a:t>Predictive timing</a:t>
+              <a:t>AI vision + insights</a:t>
             </a:r>
             <a:endParaRPr lang="en-US" sz="1600" dirty="0"/>
           </a:p>
@@ -3290,7 +3290,7 @@
                 <a:ea typeface="Calibri" pitchFamily="34" charset="-122"/>
                 <a:cs typeface="Calibri" pitchFamily="34" charset="-120"/>
               </a:rPr>
-              <a:t>AI analyzes tap patterns across all intersections</a:t>
+              <a:t>Gemini Vision analyzes every crossing for vehicle threats</a:t>
             </a:r>
             <a:endParaRPr lang="en-US" sz="1000" dirty="0"/>
           </a:p>
@@ -3313,7 +3313,7 @@
                 <a:ea typeface="Calibri" pitchFamily="34" charset="-122"/>
                 <a:cs typeface="Calibri" pitchFamily="34" charset="-120"/>
               </a:rPr>
-              <a:t>Identifies when and where seniors cross most</a:t>
+              <a:t>Flags near-misses in real time — creates safety data that doesn't exist today</a:t>
             </a:r>
             <a:endParaRPr lang="en-US" sz="1000" dirty="0"/>
           </a:p>
@@ -3359,7 +3359,7 @@
                 <a:ea typeface="Calibri" pitchFamily="34" charset="-122"/>
                 <a:cs typeface="Calibri" pitchFamily="34" charset="-120"/>
               </a:rPr>
-              <a:t>Gemini-powered natural language safety insights for SFMTA engineers</a:t>
+              <a:t>Multimodal AI: vision + natural language insights for SFMTA engineers</a:t>
             </a:r>
             <a:endParaRPr lang="en-US" sz="1000" dirty="0"/>
           </a:p>
@@ -3583,7 +3583,7 @@
       </p:sp>
       <p:pic>
         <p:nvPicPr>
-          <p:cNvPr id="8" name="Image 0" descr="preencoded.png">    </p:cNvPr>
+          <p:cNvPr id="8" name="Image 0" descr="preencoded.png"/>
           <p:cNvPicPr>
             <a:picLocks noChangeAspect="1"/>
           </p:cNvPicPr>
@@ -3685,7 +3685,7 @@
       </p:sp>
       <p:pic>
         <p:nvPicPr>
-          <p:cNvPr id="11" name="Image 1" descr="preencoded.png">    </p:cNvPr>
+          <p:cNvPr id="11" name="Image 1" descr="preencoded.png"/>
           <p:cNvPicPr>
             <a:picLocks noChangeAspect="1"/>
           </p:cNvPicPr>
@@ -3795,7 +3795,7 @@
       </p:sp>
       <p:pic>
         <p:nvPicPr>
-          <p:cNvPr id="15" name="Image 2" descr="preencoded.png">    </p:cNvPr>
+          <p:cNvPr id="15" name="Image 2" descr="preencoded.png"/>
           <p:cNvPicPr>
             <a:picLocks noChangeAspect="1"/>
           </p:cNvPicPr>
@@ -3897,7 +3897,7 @@
       </p:sp>
       <p:pic>
         <p:nvPicPr>
-          <p:cNvPr id="18" name="Image 3" descr="preencoded.png">    </p:cNvPr>
+          <p:cNvPr id="18" name="Image 3" descr="preencoded.png"/>
           <p:cNvPicPr>
             <a:picLocks noChangeAspect="1"/>
           </p:cNvPicPr>
@@ -4007,7 +4007,7 @@
       </p:sp>
       <p:pic>
         <p:nvPicPr>
-          <p:cNvPr id="22" name="Image 4" descr="preencoded.png">    </p:cNvPr>
+          <p:cNvPr id="22" name="Image 4" descr="preencoded.png"/>
           <p:cNvPicPr>
             <a:picLocks noChangeAspect="1"/>
           </p:cNvPicPr>
@@ -4109,7 +4109,7 @@
       </p:sp>
       <p:pic>
         <p:nvPicPr>
-          <p:cNvPr id="25" name="Image 5" descr="preencoded.png">    </p:cNvPr>
+          <p:cNvPr id="25" name="Image 5" descr="preencoded.png"/>
           <p:cNvPicPr>
             <a:picLocks noChangeAspect="1"/>
           </p:cNvPicPr>
@@ -4219,7 +4219,7 @@
       </p:sp>
       <p:pic>
         <p:nvPicPr>
-          <p:cNvPr id="29" name="Image 6" descr="preencoded.png">    </p:cNvPr>
+          <p:cNvPr id="29" name="Image 6" descr="preencoded.png"/>
           <p:cNvPicPr>
             <a:picLocks noChangeAspect="1"/>
           </p:cNvPicPr>
@@ -4274,7 +4274,7 @@
                 <a:ea typeface="Calibri" pitchFamily="34" charset="-122"/>
                 <a:cs typeface="Calibri" pitchFamily="34" charset="-120"/>
               </a:rPr>
-              <a:t>Data + AI</a:t>
+              <a:t>Vision + AI</a:t>
             </a:r>
             <a:endParaRPr lang="en-US" sz="1400" dirty="0"/>
           </a:p>
@@ -4313,7 +4313,7 @@
                 <a:ea typeface="Calibri" pitchFamily="34" charset="-122"/>
                 <a:cs typeface="Calibri" pitchFamily="34" charset="-120"/>
               </a:rPr>
-              <a:t>Event logged to cloud. AI analytics identify patterns. Gemini generates timing recommendations for engineers.</a:t>
+              <a:t>Gemini Vision analyzes crossing scene — flags vehicles, estimates distance. AI generates timing recommendations for engineers.</a:t>
             </a:r>
             <a:endParaRPr lang="en-US" sz="1000" dirty="0"/>
           </a:p>
@@ -4372,7 +4372,7 @@
                 <a:ea typeface="Calibri" pitchFamily="34" charset="-122"/>
                 <a:cs typeface="Calibri" pitchFamily="34" charset="-120"/>
               </a:rPr>
-              <a:t>End-to-end latency: </a:t>
+              <a:t xml:space="preserve">End-to-end latency: </a:t>
             </a:r>
             <a:pPr algn="ctr" indent="0" marL="0">
               <a:buNone/>
@@ -4400,7 +4400,7 @@
                 <a:ea typeface="Calibri" pitchFamily="34" charset="-122"/>
                 <a:cs typeface="Calibri" pitchFamily="34" charset="-120"/>
               </a:rPr>
-              <a:t>     |     Hardware per intersection: </a:t>
+              <a:t xml:space="preserve">     |     Hardware per intersection: </a:t>
             </a:r>
             <a:pPr algn="ctr" indent="0" marL="0">
               <a:buNone/>
@@ -4428,7 +4428,7 @@
                 <a:ea typeface="Calibri" pitchFamily="34" charset="-122"/>
                 <a:cs typeface="Calibri" pitchFamily="34" charset="-120"/>
               </a:rPr>
-              <a:t>     |     Safety: </a:t>
+              <a:t xml:space="preserve">     |     Safety: </a:t>
             </a:r>
             <a:pPr algn="ctr" indent="0" marL="0">
               <a:buNone/>
@@ -4659,7 +4659,7 @@
       </p:sp>
       <p:pic>
         <p:nvPicPr>
-          <p:cNvPr id="8" name="Image 0" descr="preencoded.png">    </p:cNvPr>
+          <p:cNvPr id="8" name="Image 0" descr="preencoded.png"/>
           <p:cNvPicPr>
             <a:picLocks noChangeAspect="1"/>
           </p:cNvPicPr>
@@ -4989,7 +4989,7 @@
       </p:sp>
       <p:pic>
         <p:nvPicPr>
-          <p:cNvPr id="17" name="Image 1" descr="preencoded.png">    </p:cNvPr>
+          <p:cNvPr id="17" name="Image 1" descr="preencoded.png"/>
           <p:cNvPicPr>
             <a:picLocks noChangeAspect="1"/>
           </p:cNvPicPr>
@@ -5319,7 +5319,7 @@
       </p:sp>
       <p:pic>
         <p:nvPicPr>
-          <p:cNvPr id="26" name="Image 2" descr="preencoded.png">    </p:cNvPr>
+          <p:cNvPr id="26" name="Image 2" descr="preencoded.png"/>
           <p:cNvPicPr>
             <a:picLocks noChangeAspect="1"/>
           </p:cNvPicPr>
@@ -5374,7 +5374,7 @@
                 <a:ea typeface="Calibri" pitchFamily="34" charset="-122"/>
                 <a:cs typeface="Calibri" pitchFamily="34" charset="-120"/>
               </a:rPr>
-              <a:t>AI analytics + dashboards</a:t>
+              <a:t>AI vision + analytics</a:t>
             </a:r>
             <a:endParaRPr lang="en-US" sz="1100" dirty="0"/>
           </a:p>
@@ -5430,7 +5430,7 @@
                 <a:ea typeface="Calibri" pitchFamily="34" charset="-122"/>
                 <a:cs typeface="Calibri" pitchFamily="34" charset="-120"/>
               </a:rPr>
-              <a:t>Gemini-powered insights</a:t>
+              <a:t>Gemini Vision + text insights</a:t>
             </a:r>
             <a:endParaRPr lang="en-US" sz="900" dirty="0"/>
           </a:p>
@@ -5545,7 +5545,7 @@
                 <a:ea typeface="Calibri" pitchFamily="34" charset="-122"/>
                 <a:cs typeface="Calibri" pitchFamily="34" charset="-120"/>
               </a:rPr>
-              <a:t>Pattern analysis, Gemini Q&amp;A,</a:t>
+              <a:t>Vision analysis, Gemini Q&amp;A,</a:t>
             </a:r>
             <a:endParaRPr lang="en-US" sz="800" dirty="0"/>
           </a:p>
@@ -5562,7 +5562,7 @@
                 <a:ea typeface="Calibri" pitchFamily="34" charset="-122"/>
                 <a:cs typeface="Calibri" pitchFamily="34" charset="-120"/>
               </a:rPr>
-              <a:t>HIN risk scoring, recommendations</a:t>
+              <a:t>near-miss detection, recommendations</a:t>
             </a:r>
             <a:endParaRPr lang="en-US" sz="800" dirty="0"/>
           </a:p>
@@ -5741,7 +5741,7 @@
       </p:sp>
       <p:pic>
         <p:nvPicPr>
-          <p:cNvPr id="38" name="Image 3" descr="preencoded.png">    </p:cNvPr>
+          <p:cNvPr id="38" name="Image 3" descr="preencoded.png"/>
           <p:cNvPicPr>
             <a:picLocks noChangeAspect="1"/>
           </p:cNvPicPr>
@@ -6061,7 +6061,7 @@
                 <a:ea typeface="Calibri" pitchFamily="34" charset="-122"/>
                 <a:cs typeface="Calibri" pitchFamily="34" charset="-120"/>
               </a:rPr>
-              <a:t>2. Show dashboard with live event appearing on map</a:t>
+              <a:t>2. Show dashboard — live event with AI vision badge (vehicle detected)</a:t>
             </a:r>
             <a:endParaRPr lang="en-US" sz="1000" dirty="0"/>
           </a:p>
@@ -6078,7 +6078,7 @@
                 <a:ea typeface="Calibri" pitchFamily="34" charset="-122"/>
                 <a:cs typeface="Calibri" pitchFamily="34" charset="-120"/>
               </a:rPr>
-              <a:t>3. Show AI insights panel generating a timing recommendation</a:t>
+              <a:t>3. Click intersection → Safety Analysis + AI Recommendation</a:t>
             </a:r>
             <a:endParaRPr lang="en-US" sz="1000" dirty="0"/>
           </a:p>
@@ -6138,7 +6138,7 @@
       </p:sp>
       <p:pic>
         <p:nvPicPr>
-          <p:cNvPr id="3" name="Image 0" descr="preencoded.png">    </p:cNvPr>
+          <p:cNvPr id="3" name="Image 0" descr="preencoded.png"/>
           <p:cNvPicPr>
             <a:picLocks noChangeAspect="1"/>
           </p:cNvPicPr>
@@ -6723,7 +6723,7 @@
                 <a:ea typeface="Calibri" pitchFamily="34" charset="-122"/>
                 <a:cs typeface="Calibri" pitchFamily="34" charset="-120"/>
               </a:rPr>
-              <a:t>Traditional estimate: </a:t>
+              <a:t xml:space="preserve">Traditional estimate: </a:t>
             </a:r>
             <a:pPr indent="0" marL="0">
               <a:buNone/>

</xml_diff>